<commit_message>
KV 캐시 관리자 "삼성 기여 0" 정정: LMCache에 삼성 Committer·FDP 배치 머지 (v2.46.49)
- 신규 원장 samsung-kv-cache-activities-2026-09: 19개 저장소 커밋 전수. LMCache 62건·
  Committer 1명·FDP 배치(PR #4016), Mooncake·FlexKV·Dynamo KVBM 0건
- 위키 정정: 역량 3단계·실행 전략·WAF 런타임 대응(날짜 표기)
- 덱 정정: SSD 생존 전략 3장 역량 격자, QLC 덱 5장 격차 타일·Phase 3 상태, 시각판·그림,
  QLC 보고서, 기획서
- 지식 그래프 재생성, updates.js, version v2.46.49

Co-Authored-By: Claude Opus 5.5 <noreply@anthropic.com>
Claude-Session: https://claude.ai/code/session_01VKaRpou18mADbcRisuas5a
</commit_message>
<xml_diff>
--- a/outputs/presentation/qlc-ssd-strategy-visual.pptx
+++ b/outputs/presentation/qlc-ssd-strategy-visual.pptx
@@ -788,7 +788,7 @@
           <a:lstStyle/>
           <a:p>
             <a:r>
-              <a:t>4장은 역량입니다. 상단 네 격차(내구성 2~10배, 스트림 25배, 접점 0건, 해소 수단 실증)는 삼성이 KV 캐시 스택과 연결되지 않았음을 보입니다. 왼쪽 세 Phase는 디바이스 → 워크로드 실측 → 고객 시스템 공동 설계로 역량을 확장하며, 고객 보증 범위가 정격 내 원가·전력 → 워크로드 기준 수명 → 시스템 TCO로 넓어집니다. 삼성의 현 위치는 Phase 1 진행 중(QLC 라인 RUH 2~8, DWPD 미공개, CMX 첫 공급은 TLC), Phase 2 준비(트레이스 기반 실측 미공개), Phase 3 미착수(캐시 관리자 4종 기여 0건)입니다. 오른쪽 5계층은 삼성이 닿는 층을 색으로 표시했습니다. 트레이스는 위에서 아래로 내려오고 배치 정책·규격은 관리자·앱에서 SSD로 내려옵니다. 오케스트레이션 자체는 만들지 않습니다.</a:t>
+              <a:t>4장은 역량입니다. 상단 네 격차(내구성 2~10배, 스트림 25배, 접점 1/4, 해소 수단 실증)는 삼성과 KV 캐시 스택의 연결이 아직 좁다는 것을 보입니다. 캐시 관리자 4종 중 LMCache에만 삼성 엔지니어가 Committer로 있고 FDP 배치 코드를 머지했습니다. 왼쪽 세 Phase는 디바이스 → 워크로드 실측 → 고객 시스템 공동 설계로 역량을 확장하며, 고객 보증 범위가 정격 내 원가·전력 → 워크로드 기준 수명 → 시스템 TCO로 넓어집니다. 삼성의 현 위치는 Phase 1 진행 중(QLC 라인 RUH 2~8, DWPD 미공개, CMX 첫 공급은 TLC), Phase 2 준비(트레이스 기반 실측 미공개), Phase 3 미착수(캐시 관리자 4종 기여 0건)입니다. 오른쪽 5계층은 삼성이 닿는 층을 색으로 표시했습니다. 트레이스는 위에서 아래로 내려오고 배치 정책·규격은 관리자·앱에서 SSD로 내려옵니다. 오케스트레이션 자체는 만들지 않습니다.</a:t>
             </a:r>
           </a:p>
         </p:txBody>
@@ -25828,7 +25828,7 @@
         <p:spPr>
           <a:xfrm>
             <a:off x="9390888" y="2832353"/>
-            <a:ext cx="493512" cy="333756"/>
+            <a:ext cx="629603" cy="333756"/>
           </a:xfrm>
           <a:prstGeom prst="rect">
             <a:avLst/>
@@ -25854,7 +25854,7 @@
                 <a:latin typeface="Arial"/>
                 <a:ea typeface="Arial"/>
               </a:rPr>
-              <a:t>0건</a:t>
+              <a:t>1 / 4</a:t>
             </a:r>
           </a:p>
         </p:txBody>
@@ -25867,8 +25867,8 @@
         </p:nvSpPr>
         <p:spPr>
           <a:xfrm>
-            <a:off x="9943192" y="2910077"/>
-            <a:ext cx="1783478" cy="196596"/>
+            <a:off x="10074423" y="2910077"/>
+            <a:ext cx="1834512" cy="196596"/>
           </a:xfrm>
           <a:prstGeom prst="rect">
             <a:avLst/>
@@ -25894,7 +25894,7 @@
                 <a:latin typeface="Arial"/>
                 <a:ea typeface="Arial"/>
               </a:rPr>
-              <a:t>접점 부재 · 캐시 관리자 코드</a:t>
+              <a:t>접점 시작 · LMCache만 FDP</a:t>
             </a:r>
           </a:p>
         </p:txBody>
@@ -25996,7 +25996,7 @@
         <p:spPr>
           <a:xfrm>
             <a:off x="14814418" y="2910077"/>
-            <a:ext cx="1692702" cy="196596"/>
+            <a:ext cx="1804402" cy="196596"/>
           </a:xfrm>
           <a:prstGeom prst="rect">
             <a:avLst/>
@@ -26022,7 +26022,7 @@
                 <a:latin typeface="Arial"/>
                 <a:ea typeface="Arial"/>
               </a:rPr>
-              <a:t>해소 수단 · KV 캐시 미실측</a:t>
+              <a:t>해소 수단 · KV 캐시 합성 1건</a:t>
             </a:r>
           </a:p>
         </p:txBody>
@@ -28845,97 +28845,19 @@
       </p:sp>
       <p:sp>
         <p:nvSpPr>
-          <p:cNvPr id="109" name="TextBox 108"/>
-          <p:cNvSpPr txBox="1"/>
-          <p:nvPr/>
-        </p:nvSpPr>
-        <p:spPr>
-          <a:xfrm>
-            <a:off x="7415783" y="7147179"/>
-            <a:ext cx="515428" cy="208026"/>
-          </a:xfrm>
-          <a:prstGeom prst="rect">
-            <a:avLst/>
-          </a:prstGeom>
-          <a:noFill/>
-        </p:spPr>
-        <p:txBody>
-          <a:bodyPr wrap="none" anchor="t" lIns="0" rIns="0" tIns="0" bIns="0">
-            <a:spAutoFit/>
-          </a:bodyPr>
-          <a:lstStyle/>
-          <a:p>
-            <a:pPr algn="l">
-              <a:lnSpc>
-                <a:spcPct val="125000"/>
-              </a:lnSpc>
-            </a:pPr>
-            <a:r>
-              <a:rPr sz="1080" b="1">
-                <a:solidFill>
-                  <a:srgbClr val="8A8A8A"/>
-                </a:solidFill>
-                <a:latin typeface="Arial"/>
-                <a:ea typeface="Arial"/>
-              </a:rPr>
-              <a:t>미착수</a:t>
-            </a:r>
-          </a:p>
-        </p:txBody>
-      </p:sp>
-      <p:sp>
-        <p:nvSpPr>
-          <p:cNvPr id="110" name="TextBox 109"/>
-          <p:cNvSpPr txBox="1"/>
-          <p:nvPr/>
-        </p:nvSpPr>
-        <p:spPr>
-          <a:xfrm>
-            <a:off x="1618488" y="7368921"/>
-            <a:ext cx="1460916" cy="185166"/>
-          </a:xfrm>
-          <a:prstGeom prst="rect">
-            <a:avLst/>
-          </a:prstGeom>
-          <a:noFill/>
-        </p:spPr>
-        <p:txBody>
-          <a:bodyPr wrap="none" anchor="t" lIns="0" rIns="0" tIns="0" bIns="0">
-            <a:spAutoFit/>
-          </a:bodyPr>
-          <a:lstStyle/>
-          <a:p>
-            <a:pPr algn="l">
-              <a:lnSpc>
-                <a:spcPct val="125000"/>
-              </a:lnSpc>
-            </a:pPr>
-            <a:r>
-              <a:rPr sz="936" b="0">
-                <a:solidFill>
-                  <a:srgbClr val="8A8A8A"/>
-                </a:solidFill>
-                <a:latin typeface="Arial"/>
-                <a:ea typeface="Arial"/>
-              </a:rPr>
-              <a:t>캐시 관리자 4종 기여 0건</a:t>
-            </a:r>
-          </a:p>
-        </p:txBody>
-      </p:sp>
-      <p:sp>
-        <p:nvSpPr>
-          <p:cNvPr id="111" name="Isosceles Triangle 110"/>
+          <p:cNvPr id="109" name="Rounded Rectangle 108"/>
           <p:cNvSpPr/>
           <p:nvPr/>
         </p:nvSpPr>
         <p:spPr>
           <a:xfrm>
-            <a:off x="4937760" y="4462272"/>
-            <a:ext cx="164592" cy="91440"/>
-          </a:xfrm>
-          <a:prstGeom prst="triangle">
-            <a:avLst/>
+            <a:off x="1618488" y="7168896"/>
+            <a:ext cx="453542" cy="164592"/>
+          </a:xfrm>
+          <a:prstGeom prst="roundRect">
+            <a:avLst>
+              <a:gd name="adj" fmla="val 16666"/>
+            </a:avLst>
           </a:prstGeom>
           <a:solidFill>
             <a:srgbClr val="1428A0"/>
@@ -28969,14 +28891,14 @@
       </p:sp>
       <p:sp>
         <p:nvSpPr>
-          <p:cNvPr id="112" name="TextBox 111"/>
-          <p:cNvSpPr txBox="1"/>
-          <p:nvPr/>
-        </p:nvSpPr>
-        <p:spPr>
-          <a:xfrm>
-            <a:off x="5148072" y="4534281"/>
-            <a:ext cx="764320" cy="185166"/>
+          <p:cNvPr id="110" name="TextBox 109"/>
+          <p:cNvSpPr txBox="1"/>
+          <p:nvPr/>
+        </p:nvSpPr>
+        <p:spPr>
+          <a:xfrm>
+            <a:off x="7415783" y="7147179"/>
+            <a:ext cx="374099" cy="208026"/>
           </a:xfrm>
           <a:prstGeom prst="rect">
             <a:avLst/>
@@ -28995,30 +28917,70 @@
               </a:lnSpc>
             </a:pPr>
             <a:r>
-              <a:rPr sz="936" b="1">
+              <a:rPr sz="1080" b="1">
                 <a:solidFill>
                   <a:srgbClr val="1428A0"/>
                 </a:solidFill>
                 <a:latin typeface="Arial"/>
                 <a:ea typeface="Arial"/>
               </a:rPr>
-              <a:t>삼성 현 위치</a:t>
-            </a:r>
-          </a:p>
-        </p:txBody>
-      </p:sp>
-      <p:sp>
-        <p:nvSpPr>
-          <p:cNvPr id="113" name="Rectangle 112"/>
+              <a:t>착수</a:t>
+            </a:r>
+          </a:p>
+        </p:txBody>
+      </p:sp>
+      <p:sp>
+        <p:nvSpPr>
+          <p:cNvPr id="111" name="TextBox 110"/>
+          <p:cNvSpPr txBox="1"/>
+          <p:nvPr/>
+        </p:nvSpPr>
+        <p:spPr>
+          <a:xfrm>
+            <a:off x="1618488" y="7368921"/>
+            <a:ext cx="2005716" cy="185166"/>
+          </a:xfrm>
+          <a:prstGeom prst="rect">
+            <a:avLst/>
+          </a:prstGeom>
+          <a:noFill/>
+        </p:spPr>
+        <p:txBody>
+          <a:bodyPr wrap="none" anchor="t" lIns="0" rIns="0" tIns="0" bIns="0">
+            <a:spAutoFit/>
+          </a:bodyPr>
+          <a:lstStyle/>
+          <a:p>
+            <a:pPr algn="l">
+              <a:lnSpc>
+                <a:spcPct val="125000"/>
+              </a:lnSpc>
+            </a:pPr>
+            <a:r>
+              <a:rPr sz="936" b="0">
+                <a:solidFill>
+                  <a:srgbClr val="8A8A8A"/>
+                </a:solidFill>
+                <a:latin typeface="Arial"/>
+                <a:ea typeface="Arial"/>
+              </a:rPr>
+              <a:t>LMCache만 기여 · 나머지 3종 0건</a:t>
+            </a:r>
+          </a:p>
+        </p:txBody>
+      </p:sp>
+      <p:sp>
+        <p:nvSpPr>
+          <p:cNvPr id="112" name="Isosceles Triangle 111"/>
           <p:cNvSpPr/>
           <p:nvPr/>
         </p:nvSpPr>
         <p:spPr>
           <a:xfrm>
-            <a:off x="722376" y="8467344"/>
-            <a:ext cx="16843248" cy="822960"/>
-          </a:xfrm>
-          <a:prstGeom prst="rect">
+            <a:off x="4937760" y="4462272"/>
+            <a:ext cx="164592" cy="91440"/>
+          </a:xfrm>
+          <a:prstGeom prst="triangle">
             <a:avLst/>
           </a:prstGeom>
           <a:solidFill>
@@ -29053,7 +29015,91 @@
       </p:sp>
       <p:sp>
         <p:nvSpPr>
-          <p:cNvPr id="114" name="TextBox 113"/>
+          <p:cNvPr id="113" name="TextBox 112"/>
+          <p:cNvSpPr txBox="1"/>
+          <p:nvPr/>
+        </p:nvSpPr>
+        <p:spPr>
+          <a:xfrm>
+            <a:off x="5148072" y="4534281"/>
+            <a:ext cx="764320" cy="185166"/>
+          </a:xfrm>
+          <a:prstGeom prst="rect">
+            <a:avLst/>
+          </a:prstGeom>
+          <a:noFill/>
+        </p:spPr>
+        <p:txBody>
+          <a:bodyPr wrap="none" anchor="t" lIns="0" rIns="0" tIns="0" bIns="0">
+            <a:spAutoFit/>
+          </a:bodyPr>
+          <a:lstStyle/>
+          <a:p>
+            <a:pPr algn="l">
+              <a:lnSpc>
+                <a:spcPct val="125000"/>
+              </a:lnSpc>
+            </a:pPr>
+            <a:r>
+              <a:rPr sz="936" b="1">
+                <a:solidFill>
+                  <a:srgbClr val="1428A0"/>
+                </a:solidFill>
+                <a:latin typeface="Arial"/>
+                <a:ea typeface="Arial"/>
+              </a:rPr>
+              <a:t>삼성 현 위치</a:t>
+            </a:r>
+          </a:p>
+        </p:txBody>
+      </p:sp>
+      <p:sp>
+        <p:nvSpPr>
+          <p:cNvPr id="114" name="Rectangle 113"/>
+          <p:cNvSpPr/>
+          <p:nvPr/>
+        </p:nvSpPr>
+        <p:spPr>
+          <a:xfrm>
+            <a:off x="722376" y="8467344"/>
+            <a:ext cx="16843248" cy="822960"/>
+          </a:xfrm>
+          <a:prstGeom prst="rect">
+            <a:avLst/>
+          </a:prstGeom>
+          <a:solidFill>
+            <a:srgbClr val="1428A0"/>
+          </a:solidFill>
+          <a:ln>
+            <a:noFill/>
+          </a:ln>
+          <a:effectLst/>
+        </p:spPr>
+        <p:style>
+          <a:lnRef idx="1">
+            <a:schemeClr val="accent1"/>
+          </a:lnRef>
+          <a:fillRef idx="3">
+            <a:schemeClr val="accent1"/>
+          </a:fillRef>
+          <a:effectRef idx="2">
+            <a:schemeClr val="accent1"/>
+          </a:effectRef>
+          <a:fontRef idx="minor">
+            <a:schemeClr val="lt1"/>
+          </a:fontRef>
+        </p:style>
+        <p:txBody>
+          <a:bodyPr rtlCol="0" anchor="ctr"/>
+          <a:lstStyle/>
+          <a:p>
+            <a:pPr algn="ctr"/>
+          </a:p>
+        </p:txBody>
+      </p:sp>
+      <p:sp>
+        <p:nvSpPr>
+          <p:cNvPr id="115" name="TextBox 114"/>
           <p:cNvSpPr txBox="1"/>
           <p:nvPr/>
         </p:nvSpPr>
@@ -29093,7 +29139,7 @@
       </p:sp>
       <p:sp>
         <p:nvSpPr>
-          <p:cNvPr id="115" name="TextBox 114"/>
+          <p:cNvPr id="116" name="TextBox 115"/>
           <p:cNvSpPr txBox="1"/>
           <p:nvPr/>
         </p:nvSpPr>
@@ -29133,7 +29179,7 @@
       </p:sp>
       <p:sp>
         <p:nvSpPr>
-          <p:cNvPr id="116" name="Rectangle 115"/>
+          <p:cNvPr id="117" name="Rectangle 116"/>
           <p:cNvSpPr/>
           <p:nvPr/>
         </p:nvSpPr>
@@ -29177,7 +29223,7 @@
       </p:sp>
       <p:sp>
         <p:nvSpPr>
-          <p:cNvPr id="117" name="Rectangle 116"/>
+          <p:cNvPr id="118" name="Rectangle 117"/>
           <p:cNvSpPr/>
           <p:nvPr/>
         </p:nvSpPr>
@@ -29221,7 +29267,7 @@
       </p:sp>
       <p:sp>
         <p:nvSpPr>
-          <p:cNvPr id="118" name="TextBox 117"/>
+          <p:cNvPr id="119" name="TextBox 118"/>
           <p:cNvSpPr txBox="1"/>
           <p:nvPr/>
         </p:nvSpPr>
@@ -29278,7 +29324,7 @@
       </p:sp>
       <p:sp>
         <p:nvSpPr>
-          <p:cNvPr id="119" name="TextBox 118"/>
+          <p:cNvPr id="120" name="TextBox 119"/>
           <p:cNvSpPr txBox="1"/>
           <p:nvPr/>
         </p:nvSpPr>
@@ -29318,7 +29364,7 @@
       </p:sp>
       <p:sp>
         <p:nvSpPr>
-          <p:cNvPr id="120" name="TextBox 119"/>
+          <p:cNvPr id="121" name="TextBox 120"/>
           <p:cNvSpPr txBox="1"/>
           <p:nvPr/>
         </p:nvSpPr>

</xml_diff>